<commit_message>
Updated corp overview powerpoint & added m365DSC installer.
</commit_message>
<xml_diff>
--- a/Documentation/Corp Architecture Overview.pptx
+++ b/Documentation/Corp Architecture Overview.pptx
@@ -267,7 +267,7 @@
           <a:p>
             <a:fld id="{08306F49-376E-45A5-AD65-FD4D759E20F3}" type="datetimeFigureOut">
               <a:rPr lang="en-AU" smtClean="0"/>
-              <a:t>18/08/2026</a:t>
+              <a:t>1/10/2026</a:t>
             </a:fld>
             <a:endParaRPr lang="en-AU"/>
           </a:p>
@@ -467,7 +467,7 @@
           <a:p>
             <a:fld id="{08306F49-376E-45A5-AD65-FD4D759E20F3}" type="datetimeFigureOut">
               <a:rPr lang="en-AU" smtClean="0"/>
-              <a:t>18/08/2026</a:t>
+              <a:t>1/10/2026</a:t>
             </a:fld>
             <a:endParaRPr lang="en-AU"/>
           </a:p>
@@ -677,7 +677,7 @@
           <a:p>
             <a:fld id="{08306F49-376E-45A5-AD65-FD4D759E20F3}" type="datetimeFigureOut">
               <a:rPr lang="en-AU" smtClean="0"/>
-              <a:t>18/08/2026</a:t>
+              <a:t>1/10/2026</a:t>
             </a:fld>
             <a:endParaRPr lang="en-AU"/>
           </a:p>
@@ -887,7 +887,7 @@
           <a:p>
             <a:fld id="{08306F49-376E-45A5-AD65-FD4D759E20F3}" type="datetimeFigureOut">
               <a:rPr lang="en-AU" smtClean="0"/>
-              <a:t>18/08/2026</a:t>
+              <a:t>1/10/2026</a:t>
             </a:fld>
             <a:endParaRPr lang="en-AU"/>
           </a:p>
@@ -1179,7 +1179,7 @@
           <a:p>
             <a:fld id="{08306F49-376E-45A5-AD65-FD4D759E20F3}" type="datetimeFigureOut">
               <a:rPr lang="en-AU" smtClean="0"/>
-              <a:t>18/08/2026</a:t>
+              <a:t>1/10/2026</a:t>
             </a:fld>
             <a:endParaRPr lang="en-AU"/>
           </a:p>
@@ -1447,7 +1447,7 @@
           <a:p>
             <a:fld id="{08306F49-376E-45A5-AD65-FD4D759E20F3}" type="datetimeFigureOut">
               <a:rPr lang="en-AU" smtClean="0"/>
-              <a:t>18/08/2026</a:t>
+              <a:t>1/10/2026</a:t>
             </a:fld>
             <a:endParaRPr lang="en-AU"/>
           </a:p>
@@ -1862,7 +1862,7 @@
           <a:p>
             <a:fld id="{08306F49-376E-45A5-AD65-FD4D759E20F3}" type="datetimeFigureOut">
               <a:rPr lang="en-AU" smtClean="0"/>
-              <a:t>18/08/2026</a:t>
+              <a:t>1/10/2026</a:t>
             </a:fld>
             <a:endParaRPr lang="en-AU"/>
           </a:p>
@@ -2004,7 +2004,7 @@
           <a:p>
             <a:fld id="{08306F49-376E-45A5-AD65-FD4D759E20F3}" type="datetimeFigureOut">
               <a:rPr lang="en-AU" smtClean="0"/>
-              <a:t>18/08/2026</a:t>
+              <a:t>1/10/2026</a:t>
             </a:fld>
             <a:endParaRPr lang="en-AU"/>
           </a:p>
@@ -2117,7 +2117,7 @@
           <a:p>
             <a:fld id="{08306F49-376E-45A5-AD65-FD4D759E20F3}" type="datetimeFigureOut">
               <a:rPr lang="en-AU" smtClean="0"/>
-              <a:t>18/08/2026</a:t>
+              <a:t>1/10/2026</a:t>
             </a:fld>
             <a:endParaRPr lang="en-AU"/>
           </a:p>
@@ -2430,7 +2430,7 @@
           <a:p>
             <a:fld id="{08306F49-376E-45A5-AD65-FD4D759E20F3}" type="datetimeFigureOut">
               <a:rPr lang="en-AU" smtClean="0"/>
-              <a:t>18/08/2026</a:t>
+              <a:t>1/10/2026</a:t>
             </a:fld>
             <a:endParaRPr lang="en-AU"/>
           </a:p>
@@ -2719,7 +2719,7 @@
           <a:p>
             <a:fld id="{08306F49-376E-45A5-AD65-FD4D759E20F3}" type="datetimeFigureOut">
               <a:rPr lang="en-AU" smtClean="0"/>
-              <a:t>18/08/2026</a:t>
+              <a:t>1/10/2026</a:t>
             </a:fld>
             <a:endParaRPr lang="en-AU"/>
           </a:p>
@@ -2962,7 +2962,7 @@
           <a:p>
             <a:fld id="{08306F49-376E-45A5-AD65-FD4D759E20F3}" type="datetimeFigureOut">
               <a:rPr lang="en-AU" smtClean="0"/>
-              <a:t>18/08/2026</a:t>
+              <a:t>1/10/2026</a:t>
             </a:fld>
             <a:endParaRPr lang="en-AU"/>
           </a:p>
@@ -3607,7 +3607,7 @@
         <p:spPr>
           <a:xfrm>
             <a:off x="1512217" y="3011973"/>
-            <a:ext cx="1730185" cy="3461788"/>
+            <a:ext cx="1730185" cy="1908810"/>
           </a:xfrm>
           <a:prstGeom prst="rect">
             <a:avLst/>
@@ -3635,7 +3635,7 @@
             <a:pPr algn="ctr"/>
             <a:r>
               <a:rPr lang="en-AU" sz="1200" dirty="0"/>
-              <a:t>Zenme Org Boundary</a:t>
+              <a:t>Zenblox Org Boundary</a:t>
             </a:r>
           </a:p>
         </p:txBody>
@@ -3682,7 +3682,7 @@
           <a:p>
             <a:r>
               <a:rPr lang="en-AU" sz="1200" dirty="0"/>
-              <a:t>Customer Org Boundary</a:t>
+              <a:t>Customer Private Environment</a:t>
             </a:r>
           </a:p>
         </p:txBody>
@@ -3854,7 +3854,7 @@
             <a:pPr algn="ctr"/>
             <a:r>
               <a:rPr lang="en-AU" sz="1600" dirty="0"/>
-              <a:t>-Init-</a:t>
+              <a:t>Public</a:t>
             </a:r>
           </a:p>
         </p:txBody>
@@ -3967,7 +3967,7 @@
         </p:nvSpPr>
         <p:spPr>
           <a:xfrm>
-            <a:off x="4025455" y="4740783"/>
+            <a:off x="4025455" y="4697238"/>
             <a:ext cx="1080000" cy="360000"/>
           </a:xfrm>
           <a:prstGeom prst="roundRect">
@@ -4151,7 +4151,7 @@
         <p:spPr>
           <a:xfrm>
             <a:off x="3097309" y="4405783"/>
-            <a:ext cx="928146" cy="515000"/>
+            <a:ext cx="928146" cy="471455"/>
           </a:xfrm>
           <a:prstGeom prst="line">
             <a:avLst/>
@@ -4267,60 +4267,6 @@
           </a:fontRef>
         </p:style>
       </p:cxnSp>
-      <p:sp>
-        <p:nvSpPr>
-          <p:cNvPr id="53" name="Rectangle: Rounded Corners 52">
-            <a:extLst>
-              <a:ext uri="{FF2B5EF4-FFF2-40B4-BE49-F238E27FC236}">
-                <a16:creationId xmlns:a16="http://schemas.microsoft.com/office/drawing/2014/main" id="{2059C326-2BF8-3DEF-4135-6051569E20CD}"/>
-              </a:ext>
-            </a:extLst>
-          </p:cNvPr>
-          <p:cNvSpPr/>
-          <p:nvPr/>
-        </p:nvSpPr>
-        <p:spPr>
-          <a:xfrm>
-            <a:off x="1657309" y="5695814"/>
-            <a:ext cx="1440000" cy="540000"/>
-          </a:xfrm>
-          <a:prstGeom prst="roundRect">
-            <a:avLst/>
-          </a:prstGeom>
-        </p:spPr>
-        <p:style>
-          <a:lnRef idx="2">
-            <a:schemeClr val="dk1"/>
-          </a:lnRef>
-          <a:fillRef idx="1">
-            <a:schemeClr val="lt1"/>
-          </a:fillRef>
-          <a:effectRef idx="0">
-            <a:schemeClr val="dk1"/>
-          </a:effectRef>
-          <a:fontRef idx="minor">
-            <a:schemeClr val="dk1"/>
-          </a:fontRef>
-        </p:style>
-        <p:txBody>
-          <a:bodyPr lIns="0" tIns="0" rIns="0" bIns="0" rtlCol="0" anchor="ctr"/>
-          <a:lstStyle/>
-          <a:p>
-            <a:pPr algn="ctr"/>
-            <a:r>
-              <a:rPr lang="en-AU" sz="1600" dirty="0"/>
-              <a:t>ZenInstaller</a:t>
-            </a:r>
-          </a:p>
-          <a:p>
-            <a:pPr algn="ctr"/>
-            <a:r>
-              <a:rPr lang="en-AU" sz="1600" dirty="0"/>
-              <a:t>-Deploy-</a:t>
-            </a:r>
-          </a:p>
-        </p:txBody>
-      </p:sp>
       <p:cxnSp>
         <p:nvCxnSpPr>
           <p:cNvPr id="60" name="Straight Connector 15">
@@ -4332,17 +4278,15 @@
           </p:cNvPr>
           <p:cNvCxnSpPr>
             <a:cxnSpLocks/>
-            <a:stCxn id="5" idx="2"/>
-            <a:endCxn id="53" idx="1"/>
           </p:cNvCxnSpPr>
           <p:nvPr/>
         </p:nvCxnSpPr>
         <p:spPr>
           <a:xfrm rot="16200000" flipH="1">
-            <a:off x="-81245" y="4227260"/>
-            <a:ext cx="2372300" cy="1104807"/>
-          </a:xfrm>
-          <a:prstGeom prst="curvedConnector2">
+            <a:off x="2616000" y="1486471"/>
+            <a:ext cx="1507268" cy="5634264"/>
+          </a:xfrm>
+          <a:prstGeom prst="bentConnector2">
             <a:avLst/>
           </a:prstGeom>
           <a:ln>
@@ -4383,8 +4327,8 @@
         </p:nvCxnSpPr>
         <p:spPr>
           <a:xfrm rot="5400000">
-            <a:off x="6537990" y="4242741"/>
-            <a:ext cx="1097548" cy="12700"/>
+            <a:off x="6495016" y="4285715"/>
+            <a:ext cx="1183496" cy="12700"/>
           </a:xfrm>
           <a:prstGeom prst="bentConnector3">
             <a:avLst>
@@ -4524,8 +4468,8 @@
         </p:nvCxnSpPr>
         <p:spPr>
           <a:xfrm flipH="1">
-            <a:off x="6100478" y="5286142"/>
-            <a:ext cx="986286" cy="411775"/>
+            <a:off x="6100478" y="5372090"/>
+            <a:ext cx="986286" cy="325827"/>
           </a:xfrm>
           <a:prstGeom prst="straightConnector1">
             <a:avLst/>
@@ -4568,8 +4512,8 @@
         </p:nvCxnSpPr>
         <p:spPr>
           <a:xfrm>
-            <a:off x="7086764" y="5286142"/>
-            <a:ext cx="986286" cy="411775"/>
+            <a:off x="7086764" y="5372090"/>
+            <a:ext cx="986286" cy="325827"/>
           </a:xfrm>
           <a:prstGeom prst="straightConnector1">
             <a:avLst/>
@@ -4608,7 +4552,7 @@
         </p:nvSpPr>
         <p:spPr>
           <a:xfrm>
-            <a:off x="6186764" y="4791515"/>
+            <a:off x="6186764" y="4877463"/>
             <a:ext cx="1800000" cy="494627"/>
           </a:xfrm>
           <a:prstGeom prst="roundRect">
@@ -4636,56 +4580,18 @@
             <a:pPr algn="ctr"/>
             <a:r>
               <a:rPr lang="en-AU" sz="1600" dirty="0"/>
-              <a:t>GitHub Code Deployer</a:t>
-            </a:r>
-          </a:p>
-        </p:txBody>
-      </p:sp>
-      <p:cxnSp>
-        <p:nvCxnSpPr>
-          <p:cNvPr id="92" name="Straight Connector 15">
-            <a:extLst>
-              <a:ext uri="{FF2B5EF4-FFF2-40B4-BE49-F238E27FC236}">
-                <a16:creationId xmlns:a16="http://schemas.microsoft.com/office/drawing/2014/main" id="{C0DE6055-E067-2787-FEC4-507A352F25D6}"/>
-              </a:ext>
-            </a:extLst>
-          </p:cNvPr>
-          <p:cNvCxnSpPr>
-            <a:cxnSpLocks/>
-            <a:stCxn id="53" idx="3"/>
-            <a:endCxn id="88" idx="1"/>
-          </p:cNvCxnSpPr>
-          <p:nvPr/>
-        </p:nvCxnSpPr>
-        <p:spPr>
-          <a:xfrm flipV="1">
-            <a:off x="3097309" y="5038829"/>
-            <a:ext cx="3089455" cy="926985"/>
-          </a:xfrm>
-          <a:prstGeom prst="straightConnector1">
-            <a:avLst/>
-          </a:prstGeom>
-          <a:ln>
-            <a:prstDash val="dash"/>
-            <a:headEnd type="none" w="med" len="med"/>
-            <a:tailEnd type="triangle" w="med" len="med"/>
-          </a:ln>
-        </p:spPr>
-        <p:style>
-          <a:lnRef idx="2">
-            <a:schemeClr val="accent2"/>
-          </a:lnRef>
-          <a:fillRef idx="0">
-            <a:schemeClr val="accent2"/>
-          </a:fillRef>
-          <a:effectRef idx="1">
-            <a:schemeClr val="accent2"/>
-          </a:effectRef>
-          <a:fontRef idx="minor">
-            <a:schemeClr val="tx1"/>
-          </a:fontRef>
-        </p:style>
-      </p:cxnSp>
+              <a:t>ZenInstaller </a:t>
+            </a:r>
+            <a:br>
+              <a:rPr lang="en-AU" sz="1600" dirty="0"/>
+            </a:br>
+            <a:r>
+              <a:rPr lang="en-AU" sz="1600" dirty="0"/>
+              <a:t>Private</a:t>
+            </a:r>
+          </a:p>
+        </p:txBody>
+      </p:sp>
       <p:sp>
         <p:nvSpPr>
           <p:cNvPr id="129" name="Rectangle 128">
@@ -4733,57 +4639,6 @@
             <a:r>
               <a:rPr lang="en-AU" sz="1200" dirty="0"/>
               <a:t>Init</a:t>
-            </a:r>
-          </a:p>
-        </p:txBody>
-      </p:sp>
-      <p:sp>
-        <p:nvSpPr>
-          <p:cNvPr id="130" name="Rectangle 129">
-            <a:extLst>
-              <a:ext uri="{FF2B5EF4-FFF2-40B4-BE49-F238E27FC236}">
-                <a16:creationId xmlns:a16="http://schemas.microsoft.com/office/drawing/2014/main" id="{2A8CD8E6-A312-CF1A-6C29-AAF8D4CB17BB}"/>
-              </a:ext>
-            </a:extLst>
-          </p:cNvPr>
-          <p:cNvSpPr/>
-          <p:nvPr/>
-        </p:nvSpPr>
-        <p:spPr>
-          <a:xfrm>
-            <a:off x="3425339" y="5848543"/>
-            <a:ext cx="1080000" cy="180000"/>
-          </a:xfrm>
-          <a:prstGeom prst="rect">
-            <a:avLst/>
-          </a:prstGeom>
-          <a:noFill/>
-          <a:ln>
-            <a:noFill/>
-          </a:ln>
-        </p:spPr>
-        <p:style>
-          <a:lnRef idx="2">
-            <a:schemeClr val="dk1"/>
-          </a:lnRef>
-          <a:fillRef idx="1">
-            <a:schemeClr val="lt1"/>
-          </a:fillRef>
-          <a:effectRef idx="0">
-            <a:schemeClr val="dk1"/>
-          </a:effectRef>
-          <a:fontRef idx="minor">
-            <a:schemeClr val="dk1"/>
-          </a:fontRef>
-        </p:style>
-        <p:txBody>
-          <a:bodyPr lIns="0" tIns="0" rIns="0" bIns="0" rtlCol="0" anchor="ctr"/>
-          <a:lstStyle/>
-          <a:p>
-            <a:pPr algn="ctr"/>
-            <a:r>
-              <a:rPr lang="en-AU" sz="1200" dirty="0"/>
-              <a:t>Deploy</a:t>
             </a:r>
           </a:p>
         </p:txBody>
@@ -5046,7 +4901,7 @@
         </p:nvSpPr>
         <p:spPr>
           <a:xfrm>
-            <a:off x="1031733" y="5397283"/>
+            <a:off x="783328" y="5245268"/>
             <a:ext cx="595093" cy="264618"/>
           </a:xfrm>
           <a:prstGeom prst="rect">
@@ -5077,155 +4932,13 @@
           <a:p>
             <a:pPr algn="ctr"/>
             <a:r>
-              <a:rPr lang="en-AU" sz="1200" dirty="0"/>
-              <a:t>Deploy #95</a:t>
-            </a:r>
-          </a:p>
-        </p:txBody>
-      </p:sp>
-      <p:sp>
-        <p:nvSpPr>
-          <p:cNvPr id="30" name="Rectangle 29">
-            <a:extLst>
-              <a:ext uri="{FF2B5EF4-FFF2-40B4-BE49-F238E27FC236}">
-                <a16:creationId xmlns:a16="http://schemas.microsoft.com/office/drawing/2014/main" id="{CDB9701A-55C7-DD15-EC87-31D6B71CFBB5}"/>
-              </a:ext>
-            </a:extLst>
-          </p:cNvPr>
-          <p:cNvSpPr/>
-          <p:nvPr/>
-        </p:nvSpPr>
-        <p:spPr>
-          <a:xfrm>
-            <a:off x="197122" y="6131085"/>
-            <a:ext cx="987065" cy="461442"/>
-          </a:xfrm>
-          <a:prstGeom prst="rect">
-            <a:avLst/>
-          </a:prstGeom>
-          <a:noFill/>
-          <a:ln>
-            <a:noFill/>
-          </a:ln>
-        </p:spPr>
-        <p:style>
-          <a:lnRef idx="2">
-            <a:schemeClr val="dk1"/>
-          </a:lnRef>
-          <a:fillRef idx="1">
-            <a:schemeClr val="lt1"/>
-          </a:fillRef>
-          <a:effectRef idx="0">
-            <a:schemeClr val="dk1"/>
-          </a:effectRef>
-          <a:fontRef idx="minor">
-            <a:schemeClr val="dk1"/>
-          </a:fontRef>
-        </p:style>
-        <p:txBody>
-          <a:bodyPr lIns="0" tIns="0" rIns="0" bIns="0" rtlCol="0" anchor="ctr"/>
-          <a:lstStyle/>
-          <a:p>
-            <a:pPr algn="ctr"/>
-            <a:r>
-              <a:rPr lang="en-AU" sz="1200" dirty="0"/>
-              <a:t>Approve Deployment #95</a:t>
-            </a:r>
-          </a:p>
-        </p:txBody>
-      </p:sp>
-      <p:cxnSp>
-        <p:nvCxnSpPr>
-          <p:cNvPr id="32" name="Connector: Elbow 31">
-            <a:extLst>
-              <a:ext uri="{FF2B5EF4-FFF2-40B4-BE49-F238E27FC236}">
-                <a16:creationId xmlns:a16="http://schemas.microsoft.com/office/drawing/2014/main" id="{F51D9240-9055-7D5B-43A3-A8BAF50DF7E4}"/>
-              </a:ext>
-            </a:extLst>
-          </p:cNvPr>
-          <p:cNvCxnSpPr>
-            <a:cxnSpLocks/>
-            <a:stCxn id="5" idx="1"/>
-            <a:endCxn id="72" idx="2"/>
-          </p:cNvCxnSpPr>
-          <p:nvPr/>
-        </p:nvCxnSpPr>
-        <p:spPr>
-          <a:xfrm rot="10800000" flipH="1" flipV="1">
-            <a:off x="312788" y="3333163"/>
-            <a:ext cx="5787689" cy="2724753"/>
-          </a:xfrm>
-          <a:prstGeom prst="bentConnector4">
-            <a:avLst>
-              <a:gd name="adj1" fmla="val -3950"/>
-              <a:gd name="adj2" fmla="val 123992"/>
-            </a:avLst>
-          </a:prstGeom>
-          <a:ln>
-            <a:tailEnd type="triangle"/>
-          </a:ln>
-        </p:spPr>
-        <p:style>
-          <a:lnRef idx="2">
-            <a:schemeClr val="accent2"/>
-          </a:lnRef>
-          <a:fillRef idx="0">
-            <a:schemeClr val="accent2"/>
-          </a:fillRef>
-          <a:effectRef idx="1">
-            <a:schemeClr val="accent2"/>
-          </a:effectRef>
-          <a:fontRef idx="minor">
-            <a:schemeClr val="tx1"/>
-          </a:fontRef>
-        </p:style>
-      </p:cxnSp>
-      <p:cxnSp>
-        <p:nvCxnSpPr>
-          <p:cNvPr id="40" name="Connector: Elbow 39">
-            <a:extLst>
-              <a:ext uri="{FF2B5EF4-FFF2-40B4-BE49-F238E27FC236}">
-                <a16:creationId xmlns:a16="http://schemas.microsoft.com/office/drawing/2014/main" id="{7CF9E605-4607-D4D3-E7E3-F00C93BB99F0}"/>
-              </a:ext>
-            </a:extLst>
-          </p:cNvPr>
-          <p:cNvCxnSpPr>
-            <a:cxnSpLocks/>
-            <a:stCxn id="5" idx="1"/>
-            <a:endCxn id="73" idx="2"/>
-          </p:cNvCxnSpPr>
-          <p:nvPr/>
-        </p:nvCxnSpPr>
-        <p:spPr>
-          <a:xfrm rot="10800000" flipH="1" flipV="1">
-            <a:off x="312788" y="3333163"/>
-            <a:ext cx="7760261" cy="2724753"/>
-          </a:xfrm>
-          <a:prstGeom prst="bentConnector4">
-            <a:avLst>
-              <a:gd name="adj1" fmla="val -2946"/>
-              <a:gd name="adj2" fmla="val 123698"/>
-            </a:avLst>
-          </a:prstGeom>
-          <a:ln>
-            <a:tailEnd type="triangle"/>
-          </a:ln>
-        </p:spPr>
-        <p:style>
-          <a:lnRef idx="2">
-            <a:schemeClr val="accent2"/>
-          </a:lnRef>
-          <a:fillRef idx="0">
-            <a:schemeClr val="accent2"/>
-          </a:fillRef>
-          <a:effectRef idx="1">
-            <a:schemeClr val="accent2"/>
-          </a:effectRef>
-          <a:fontRef idx="minor">
-            <a:schemeClr val="tx1"/>
-          </a:fontRef>
-        </p:style>
-      </p:cxnSp>
+              <a:rPr lang="en-AU" sz="1200"/>
+              <a:t>Deploy</a:t>
+            </a:r>
+            <a:endParaRPr lang="en-AU" sz="1200" dirty="0"/>
+          </a:p>
+        </p:txBody>
+      </p:sp>
     </p:spTree>
     <p:extLst>
       <p:ext uri="{BB962C8B-B14F-4D97-AF65-F5344CB8AC3E}">

</xml_diff>